<commit_message>
Update README with Demo Video Drive link, finalize PPTX deck, and add presentation tooling
</commit_message>
<xml_diff>
--- a/submission/CollegeName_TeamName_Submission.pptx
+++ b/submission/CollegeName_TeamName_Submission.pptx
@@ -15000,45 +15000,6 @@
         </p:nvSpPr>
         <p:spPr>
           <a:xfrm>
-            <a:off x="800000" y="2440000"/>
-            <a:ext cx="10592000" cy="300000"/>
-          </a:xfrm>
-          <a:prstGeom prst="rect">
-            <a:avLst/>
-          </a:prstGeom>
-          <a:noFill/>
-        </p:spPr>
-        <p:txBody>
-          <a:bodyPr wrap="square" lIns="0" rIns="0" tIns="0" bIns="0">
-            <a:spAutoFit/>
-          </a:bodyPr>
-          <a:lstStyle/>
-          <a:p>
-            <a:pPr algn="l">
-              <a:lnSpc>
-                <a:spcPct val="115000"/>
-              </a:lnSpc>
-            </a:pPr>
-            <a:r>
-              <a:rPr sz="1250" b="1">
-                <a:solidFill>
-                  <a:srgbClr val="0F9D58"/>
-                </a:solidFill>
-                <a:latin typeface="Arial"/>
-              </a:rPr>
-              <a:t>200 OK  ·  latency 5 ms  ·  tier miss  ·  plan   ·  model none(rules)</a:t>
-            </a:r>
-          </a:p>
-        </p:txBody>
-      </p:sp>
-      <p:sp>
-        <p:nvSpPr>
-          <p:cNvPr id="6" name="TextBox 5"/>
-          <p:cNvSpPr txBox="1"/>
-          <p:nvPr/>
-        </p:nvSpPr>
-        <p:spPr>
-          <a:xfrm>
             <a:off x="800000" y="2800000"/>
             <a:ext cx="10592000" cy="2600000"/>
           </a:xfrm>
@@ -15072,14 +15033,14 @@
       </p:sp>
       <p:sp>
         <p:nvSpPr>
-          <p:cNvPr id="7" name="TextBox 6"/>
+          <p:cNvPr id="6" name="TextBox 5"/>
           <p:cNvSpPr txBox="1"/>
           <p:nvPr/>
         </p:nvSpPr>
         <p:spPr>
           <a:xfrm>
-            <a:off x="800000" y="5500000"/>
-            <a:ext cx="10592000" cy="400000"/>
+            <a:off x="800000" y="5600000"/>
+            <a:ext cx="10592000" cy="350000"/>
           </a:xfrm>
           <a:prstGeom prst="rect">
             <a:avLst/>
@@ -15098,13 +15059,13 @@
               </a:lnSpc>
             </a:pPr>
             <a:r>
-              <a:rPr sz="1200" b="0">
-                <a:solidFill>
-                  <a:srgbClr val="5F6368"/>
+              <a:rPr sz="1200" b="1">
+                <a:solidFill>
+                  <a:srgbClr val="1428A0"/>
                 </a:solidFill>
                 <a:latin typeface="Arial"/>
               </a:rPr>
-              <a:t>Demo video: 5 min — cold request, warm request, paraphrase, multi-intent fan-out, no-match fallback, and the /v1/metrics counter moving.</a:t>
+              <a:t>Demo video (Drive link): https://drive.google.com/drive/folders/1QrjJKvw05YEvInxOWxkgEMnecfP9hlbw?usp=sharing</a:t>
             </a:r>
           </a:p>
         </p:txBody>

</xml_diff>